<commit_message>
core editor config fix
</commit_message>
<xml_diff>
--- a/GIT pagrindai.pptx
+++ b/GIT pagrindai.pptx
@@ -23881,15 +23881,15 @@
             </a:pPr>
             <a:r>
               <a:rPr lang="fr-FR" sz="2800" b="1" dirty="0"/>
-              <a:t>git config --</a:t>
-            </a:r>
-            <a:r>
-              <a:rPr lang="fr-FR" sz="2800" b="1" dirty="0" err="1"/>
-              <a:t>add</a:t>
+              <a:t>git </a:t>
+            </a:r>
+            <a:r>
+              <a:rPr lang="fr-FR" sz="2800" b="1"/>
+              <a:t>config --</a:t>
             </a:r>
             <a:r>
               <a:rPr lang="fr-FR" sz="2800" b="1" dirty="0"/>
-              <a:t> --system </a:t>
+              <a:t>system </a:t>
             </a:r>
             <a:r>
               <a:rPr lang="fr-FR" sz="2800" b="1" dirty="0" err="1"/>

</xml_diff>